<commit_message>
CASA blue/yellow for Speakers and Graduations; add 8 story templates
Co-Authored-By: Claude Opus 5.5 <noreply@anthropic.com>
Claude-Session: https://claude.ai/code/session_01RnMzsxqDMfgar4HrYCdSBS
</commit_message>
<xml_diff>
--- a/templates/05-speakers.pptx
+++ b/templates/05-speakers.pptx
@@ -3168,7 +3168,7 @@
       <p:grpSpPr/>
       <p:pic>
         <p:nvPicPr>
-          <p:cNvPr id="2" name="Picture 1" descr="clip-placeholder-E3A53B.jpg"/>
+          <p:cNvPr id="2" name="Picture 1" descr="clip-placeholder-1648C4.jpg"/>
           <p:cNvPicPr>
             <a:picLocks noChangeAspect="1"/>
           </p:cNvPicPr>
@@ -3207,7 +3207,7 @@
             </a:avLst>
           </a:prstGeom>
           <a:solidFill>
-            <a:srgbClr val="E3A53B"/>
+            <a:srgbClr val="1648C4"/>
           </a:solidFill>
           <a:ln>
             <a:noFill/>
@@ -3429,7 +3429,7 @@
             <a:r>
               <a:rPr sz="4950" b="1">
                 <a:solidFill>
-                  <a:srgbClr val="E3A53B"/>
+                  <a:srgbClr val="1648C4"/>
                 </a:solidFill>
                 <a:latin typeface="Montserrat"/>
               </a:rPr>
@@ -3458,7 +3458,7 @@
       <p:grpSpPr/>
       <p:pic>
         <p:nvPicPr>
-          <p:cNvPr id="2" name="Picture 1" descr="clip-placeholder-E3A53B.jpg"/>
+          <p:cNvPr id="2" name="Picture 1" descr="clip-placeholder-1648C4.jpg"/>
           <p:cNvPicPr>
             <a:picLocks noChangeAspect="1"/>
           </p:cNvPicPr>
@@ -3497,7 +3497,7 @@
             </a:avLst>
           </a:prstGeom>
           <a:solidFill>
-            <a:srgbClr val="E3A53B"/>
+            <a:srgbClr val="1648C4"/>
           </a:solidFill>
           <a:ln>
             <a:noFill/>
@@ -3633,7 +3633,7 @@
             <a:r>
               <a:rPr sz="2100" b="1" spc="400">
                 <a:solidFill>
-                  <a:srgbClr val="E3A53B"/>
+                  <a:srgbClr val="1648C4"/>
                 </a:solidFill>
                 <a:latin typeface="Montserrat"/>
               </a:rPr>
@@ -3681,7 +3681,7 @@
             <a:r>
               <a:rPr sz="6000" b="1">
                 <a:solidFill>
-                  <a:srgbClr val="E3A53B"/>
+                  <a:srgbClr val="1648C4"/>
                 </a:solidFill>
                 <a:latin typeface="Montserrat"/>
               </a:rPr>
@@ -3745,7 +3745,7 @@
       <p:grpSpPr/>
       <p:pic>
         <p:nvPicPr>
-          <p:cNvPr id="2" name="Picture 1" descr="clip-placeholder-E3A53B.jpg"/>
+          <p:cNvPr id="2" name="Picture 1" descr="clip-placeholder-1648C4.jpg"/>
           <p:cNvPicPr>
             <a:picLocks noChangeAspect="1"/>
           </p:cNvPicPr>
@@ -3885,7 +3885,7 @@
             <a:r>
               <a:rPr sz="6900" b="1">
                 <a:solidFill>
-                  <a:srgbClr val="E3A53B"/>
+                  <a:srgbClr val="1648C4"/>
                 </a:solidFill>
                 <a:latin typeface="Montserrat"/>
               </a:rPr>
@@ -3914,7 +3914,7 @@
       <p:grpSpPr/>
       <p:pic>
         <p:nvPicPr>
-          <p:cNvPr id="2" name="Picture 1" descr="clip-placeholder-E3A53B.jpg"/>
+          <p:cNvPr id="2" name="Picture 1" descr="clip-placeholder-1648C4.jpg"/>
           <p:cNvPicPr>
             <a:picLocks noChangeAspect="1"/>
           </p:cNvPicPr>
@@ -3953,7 +3953,7 @@
             </a:avLst>
           </a:prstGeom>
           <a:solidFill>
-            <a:srgbClr val="E3A53B"/>
+            <a:srgbClr val="1648C4"/>
           </a:solidFill>
           <a:ln>
             <a:noFill/>

</xml_diff>